<commit_message>
Add boosting nodes and slides
</commit_message>
<xml_diff>
--- a/slides/11-decision-trees.pptx
+++ b/slides/11-decision-trees.pptx
@@ -225,7 +225,7 @@
           <a:p>
             <a:fld id="{A5320152-7289-42ED-97D3-BBB411F9F8C0}" type="datetimeFigureOut">
               <a:rPr lang="en-US" smtClean="0"/>
-              <a:t>2/24/2026</a:t>
+              <a:t>2/26/2026</a:t>
             </a:fld>
             <a:endParaRPr lang="en-US"/>
           </a:p>
@@ -645,7 +645,7 @@
           <a:p>
             <a:fld id="{D1D1EADE-8E88-4C7C-8AC5-FB148DE4940E}" type="datetime1">
               <a:rPr lang="en-US" smtClean="0"/>
-              <a:t>2/24/2026</a:t>
+              <a:t>2/26/2026</a:t>
             </a:fld>
             <a:endParaRPr lang="en-US"/>
           </a:p>
@@ -845,7 +845,7 @@
           <a:p>
             <a:fld id="{EC3C8B9C-477D-492A-96AD-1FC2CC997A73}" type="datetime1">
               <a:rPr lang="en-US" smtClean="0"/>
-              <a:t>2/24/2026</a:t>
+              <a:t>2/26/2026</a:t>
             </a:fld>
             <a:endParaRPr lang="en-US"/>
           </a:p>
@@ -1055,7 +1055,7 @@
           <a:p>
             <a:fld id="{42D3AED5-E26D-4E29-B1B3-7847B6779594}" type="datetime1">
               <a:rPr lang="en-US" smtClean="0"/>
-              <a:t>2/24/2026</a:t>
+              <a:t>2/26/2026</a:t>
             </a:fld>
             <a:endParaRPr lang="en-US"/>
           </a:p>
@@ -1378,7 +1378,7 @@
           <a:p>
             <a:fld id="{157B6794-849E-4626-908B-D15793550EFB}" type="datetime1">
               <a:rPr lang="en-US" smtClean="0"/>
-              <a:t>2/24/2026</a:t>
+              <a:t>2/26/2026</a:t>
             </a:fld>
             <a:endParaRPr lang="en-US"/>
           </a:p>
@@ -1654,7 +1654,7 @@
           <a:p>
             <a:fld id="{63DB64E7-5594-42A3-ADBF-E95A7ACEAD64}" type="datetime1">
               <a:rPr lang="en-US" smtClean="0"/>
-              <a:t>2/24/2026</a:t>
+              <a:t>2/26/2026</a:t>
             </a:fld>
             <a:endParaRPr lang="en-US"/>
           </a:p>
@@ -1927,7 +1927,7 @@
           <a:p>
             <a:fld id="{18462B0B-D248-4FFB-8695-AD7FA4B1284A}" type="datetime1">
               <a:rPr lang="en-US" smtClean="0"/>
-              <a:t>2/24/2026</a:t>
+              <a:t>2/26/2026</a:t>
             </a:fld>
             <a:endParaRPr lang="en-US"/>
           </a:p>
@@ -2350,7 +2350,7 @@
           <a:p>
             <a:fld id="{D0378EFB-9159-4510-B73F-4F0409ADE937}" type="datetime1">
               <a:rPr lang="en-US" smtClean="0"/>
-              <a:t>2/24/2026</a:t>
+              <a:t>2/26/2026</a:t>
             </a:fld>
             <a:endParaRPr lang="en-US"/>
           </a:p>
@@ -2492,7 +2492,7 @@
           <a:p>
             <a:fld id="{89BC9412-2452-4BED-A324-9D8C115361AD}" type="datetime1">
               <a:rPr lang="en-US" smtClean="0"/>
-              <a:t>2/24/2026</a:t>
+              <a:t>2/26/2026</a:t>
             </a:fld>
             <a:endParaRPr lang="en-US"/>
           </a:p>
@@ -2605,7 +2605,7 @@
           <a:p>
             <a:fld id="{F5318F62-D251-40E8-A23C-F4CFE9FEAB41}" type="datetime1">
               <a:rPr lang="en-US" smtClean="0"/>
-              <a:t>2/24/2026</a:t>
+              <a:t>2/26/2026</a:t>
             </a:fld>
             <a:endParaRPr lang="en-US"/>
           </a:p>
@@ -2918,7 +2918,7 @@
           <a:p>
             <a:fld id="{44F76144-149E-4874-93A5-554A0357CF82}" type="datetime1">
               <a:rPr lang="en-US" smtClean="0"/>
-              <a:t>2/24/2026</a:t>
+              <a:t>2/26/2026</a:t>
             </a:fld>
             <a:endParaRPr lang="en-US"/>
           </a:p>
@@ -3211,7 +3211,7 @@
           <a:p>
             <a:fld id="{50BA65D8-0540-4835-AE5C-25D29DBA01BE}" type="datetime1">
               <a:rPr lang="en-US" smtClean="0"/>
-              <a:t>2/24/2026</a:t>
+              <a:t>2/26/2026</a:t>
             </a:fld>
             <a:endParaRPr lang="en-US"/>
           </a:p>
@@ -3453,7 +3453,7 @@
           <a:p>
             <a:fld id="{E31BA835-12AC-4E8F-955A-EA3F4DE2791F}" type="datetime1">
               <a:rPr lang="en-US" smtClean="0"/>
-              <a:t>2/24/2026</a:t>
+              <a:t>2/26/2026</a:t>
             </a:fld>
             <a:endParaRPr lang="en-US"/>
           </a:p>
@@ -5466,7 +5466,7 @@
           </a:ln>
           <a:extLst>
             <a:ext uri="{C572A759-6A51-4108-AA02-DFA0A04FC94B}">
-              <ma14:wrappingTextBoxFlag xmlns:ma14="http://schemas.microsoft.com/office/mac/drawingml/2011/main" xmlns:a14="http://schemas.microsoft.com/office/drawing/2010/main" xmlns:m="http://schemas.openxmlformats.org/officeDocument/2006/math" xmlns="" val="1"/>
+              <ma14:wrappingTextBoxFlag xmlns="" xmlns:m="http://schemas.openxmlformats.org/officeDocument/2006/math" xmlns:a14="http://schemas.microsoft.com/office/drawing/2010/main" xmlns:ma14="http://schemas.microsoft.com/office/mac/drawingml/2011/main" val="1"/>
             </a:ext>
           </a:extLst>
         </p:spPr>
@@ -5559,7 +5559,7 @@
           </a:ln>
           <a:extLst>
             <a:ext uri="{C572A759-6A51-4108-AA02-DFA0A04FC94B}">
-              <ma14:wrappingTextBoxFlag xmlns:ma14="http://schemas.microsoft.com/office/mac/drawingml/2011/main" xmlns:a14="http://schemas.microsoft.com/office/drawing/2010/main" xmlns:m="http://schemas.openxmlformats.org/officeDocument/2006/math" xmlns="" val="1"/>
+              <ma14:wrappingTextBoxFlag xmlns="" xmlns:m="http://schemas.openxmlformats.org/officeDocument/2006/math" xmlns:a14="http://schemas.microsoft.com/office/drawing/2010/main" xmlns:ma14="http://schemas.microsoft.com/office/mac/drawingml/2011/main" val="1"/>
             </a:ext>
           </a:extLst>
         </p:spPr>
@@ -5864,7 +5864,7 @@
           </a:ln>
           <a:extLst>
             <a:ext uri="{C572A759-6A51-4108-AA02-DFA0A04FC94B}">
-              <ma14:wrappingTextBoxFlag xmlns:ma14="http://schemas.microsoft.com/office/mac/drawingml/2011/main" xmlns:a14="http://schemas.microsoft.com/office/drawing/2010/main" xmlns:m="http://schemas.openxmlformats.org/officeDocument/2006/math" xmlns="" val="1"/>
+              <ma14:wrappingTextBoxFlag xmlns="" xmlns:m="http://schemas.openxmlformats.org/officeDocument/2006/math" xmlns:a14="http://schemas.microsoft.com/office/drawing/2010/main" xmlns:ma14="http://schemas.microsoft.com/office/mac/drawingml/2011/main" val="1"/>
             </a:ext>
           </a:extLst>
         </p:spPr>
@@ -6924,7 +6924,7 @@
                             </p:stCondLst>
                             <p:childTnLst>
                               <p:par>
-                                <p:cTn id="5" presetID="10" presetClass="entr" presetSubtype="0" fill="hold" nodeType="clickEffect">
+                                <p:cTn id="5" presetID="1" presetClass="entr" presetSubtype="0" fill="hold" nodeType="clickEffect">
                                   <p:stCondLst>
                                     <p:cond delay="0"/>
                                   </p:stCondLst>
@@ -6951,18 +6951,6 @@
                                         <p:strVal val="visible"/>
                                       </p:to>
                                     </p:set>
-                                    <p:animEffect transition="in" filter="fade">
-                                      <p:cBhvr>
-                                        <p:cTn id="7" dur="500"/>
-                                        <p:tgtEl>
-                                          <p:spTgt spid="2">
-                                            <p:txEl>
-                                              <p:pRg st="2" end="2"/>
-                                            </p:txEl>
-                                          </p:spTgt>
-                                        </p:tgtEl>
-                                      </p:cBhvr>
-                                    </p:animEffect>
                                   </p:childTnLst>
                                 </p:cTn>
                               </p:par>
@@ -6973,26 +6961,26 @@
                     </p:cTn>
                   </p:par>
                   <p:par>
-                    <p:cTn id="8" fill="hold">
+                    <p:cTn id="7" fill="hold">
                       <p:stCondLst>
                         <p:cond delay="indefinite"/>
                       </p:stCondLst>
                       <p:childTnLst>
                         <p:par>
-                          <p:cTn id="9" fill="hold">
+                          <p:cTn id="8" fill="hold">
                             <p:stCondLst>
                               <p:cond delay="0"/>
                             </p:stCondLst>
                             <p:childTnLst>
                               <p:par>
-                                <p:cTn id="10" presetID="1" presetClass="entr" presetSubtype="0" fill="hold" nodeType="clickEffect">
+                                <p:cTn id="9" presetID="1" presetClass="entr" presetSubtype="0" fill="hold" nodeType="clickEffect">
                                   <p:stCondLst>
                                     <p:cond delay="0"/>
                                   </p:stCondLst>
                                   <p:childTnLst>
                                     <p:set>
                                       <p:cBhvr>
-                                        <p:cTn id="11" dur="1" fill="hold">
+                                        <p:cTn id="10" dur="1" fill="hold">
                                           <p:stCondLst>
                                             <p:cond delay="0"/>
                                           </p:stCondLst>
@@ -7022,26 +7010,26 @@
                     </p:cTn>
                   </p:par>
                   <p:par>
-                    <p:cTn id="12" fill="hold">
+                    <p:cTn id="11" fill="hold">
                       <p:stCondLst>
                         <p:cond delay="indefinite"/>
                       </p:stCondLst>
                       <p:childTnLst>
                         <p:par>
-                          <p:cTn id="13" fill="hold">
+                          <p:cTn id="12" fill="hold">
                             <p:stCondLst>
                               <p:cond delay="0"/>
                             </p:stCondLst>
                             <p:childTnLst>
                               <p:par>
-                                <p:cTn id="14" presetID="1" presetClass="entr" presetSubtype="0" fill="hold" nodeType="clickEffect">
+                                <p:cTn id="13" presetID="1" presetClass="entr" presetSubtype="0" fill="hold" nodeType="clickEffect">
                                   <p:stCondLst>
                                     <p:cond delay="0"/>
                                   </p:stCondLst>
                                   <p:childTnLst>
                                     <p:set>
                                       <p:cBhvr>
-                                        <p:cTn id="15" dur="1" fill="hold">
+                                        <p:cTn id="14" dur="1" fill="hold">
                                           <p:stCondLst>
                                             <p:cond delay="0"/>
                                           </p:stCondLst>
@@ -7071,26 +7059,26 @@
                     </p:cTn>
                   </p:par>
                   <p:par>
-                    <p:cTn id="16" fill="hold">
+                    <p:cTn id="15" fill="hold">
                       <p:stCondLst>
                         <p:cond delay="indefinite"/>
                       </p:stCondLst>
                       <p:childTnLst>
                         <p:par>
-                          <p:cTn id="17" fill="hold">
+                          <p:cTn id="16" fill="hold">
                             <p:stCondLst>
                               <p:cond delay="0"/>
                             </p:stCondLst>
                             <p:childTnLst>
                               <p:par>
-                                <p:cTn id="18" presetID="1" presetClass="entr" presetSubtype="0" fill="hold" nodeType="clickEffect">
+                                <p:cTn id="17" presetID="1" presetClass="entr" presetSubtype="0" fill="hold" nodeType="clickEffect">
                                   <p:stCondLst>
                                     <p:cond delay="0"/>
                                   </p:stCondLst>
                                   <p:childTnLst>
                                     <p:set>
                                       <p:cBhvr>
-                                        <p:cTn id="19" dur="1" fill="hold">
+                                        <p:cTn id="18" dur="1" fill="hold">
                                           <p:stCondLst>
                                             <p:cond delay="0"/>
                                           </p:stCondLst>
@@ -11109,7 +11097,7 @@
               </a:ln>
               <a:extLst>
                 <a:ext uri="{C572A759-6A51-4108-AA02-DFA0A04FC94B}">
-                  <ma14:wrappingTextBoxFlag xmlns:ma14="http://schemas.microsoft.com/office/mac/drawingml/2011/main" xmlns:m="http://schemas.openxmlformats.org/officeDocument/2006/math" xmlns="" val="1"/>
+                  <ma14:wrappingTextBoxFlag xmlns="" xmlns:m="http://schemas.openxmlformats.org/officeDocument/2006/math" xmlns:ma14="http://schemas.microsoft.com/office/mac/drawingml/2011/main" val="1"/>
                 </a:ext>
               </a:extLst>
             </p:spPr>
@@ -11229,7 +11217,7 @@
           </a:ln>
           <a:extLst>
             <a:ext uri="{C572A759-6A51-4108-AA02-DFA0A04FC94B}">
-              <ma14:wrappingTextBoxFlag xmlns:ma14="http://schemas.microsoft.com/office/mac/drawingml/2011/main" xmlns:a14="http://schemas.microsoft.com/office/drawing/2010/main" xmlns:m="http://schemas.openxmlformats.org/officeDocument/2006/math" xmlns="" val="1"/>
+              <ma14:wrappingTextBoxFlag xmlns="" xmlns:m="http://schemas.openxmlformats.org/officeDocument/2006/math" xmlns:a14="http://schemas.microsoft.com/office/drawing/2010/main" xmlns:ma14="http://schemas.microsoft.com/office/mac/drawingml/2011/main" val="1"/>
             </a:ext>
           </a:extLst>
         </p:spPr>
@@ -11279,7 +11267,7 @@
           </a:ln>
           <a:extLst>
             <a:ext uri="{C572A759-6A51-4108-AA02-DFA0A04FC94B}">
-              <ma14:wrappingTextBoxFlag xmlns:ma14="http://schemas.microsoft.com/office/mac/drawingml/2011/main" xmlns:a14="http://schemas.microsoft.com/office/drawing/2010/main" xmlns:m="http://schemas.openxmlformats.org/officeDocument/2006/math" xmlns="" val="1"/>
+              <ma14:wrappingTextBoxFlag xmlns="" xmlns:m="http://schemas.openxmlformats.org/officeDocument/2006/math" xmlns:a14="http://schemas.microsoft.com/office/drawing/2010/main" xmlns:ma14="http://schemas.microsoft.com/office/mac/drawingml/2011/main" val="1"/>
             </a:ext>
           </a:extLst>
         </p:spPr>
@@ -11434,7 +11422,25 @@
                         </a:solidFill>
                         <a:latin typeface="Cambria Math" panose="02040503050406030204" pitchFamily="18" charset="0"/>
                       </a:rPr>
-                      <m:t>=1−</m:t>
+                      <m:t>=</m:t>
+                    </m:r>
+                    <m:r>
+                      <a:rPr sz="2285" i="1">
+                        <a:solidFill>
+                          <a:srgbClr val="000000"/>
+                        </a:solidFill>
+                        <a:latin typeface="Cambria Math" panose="02040503050406030204" pitchFamily="18" charset="0"/>
+                      </a:rPr>
+                      <m:t>1</m:t>
+                    </m:r>
+                    <m:r>
+                      <a:rPr sz="2285" i="1">
+                        <a:solidFill>
+                          <a:srgbClr val="000000"/>
+                        </a:solidFill>
+                        <a:latin typeface="Cambria Math" panose="02040503050406030204" pitchFamily="18" charset="0"/>
+                      </a:rPr>
+                      <m:t>−</m:t>
                     </m:r>
                     <m:limUpp>
                       <m:limUppPr>
@@ -11487,7 +11493,16 @@
                                 </a:solidFill>
                                 <a:latin typeface="Cambria Math" panose="02040503050406030204" pitchFamily="18" charset="0"/>
                               </a:rPr>
-                              <m:t>=1</m:t>
+                              <m:t>=</m:t>
+                            </m:r>
+                            <m:r>
+                              <a:rPr sz="2285" i="1">
+                                <a:solidFill>
+                                  <a:srgbClr val="000000"/>
+                                </a:solidFill>
+                                <a:latin typeface="Cambria Math" panose="02040503050406030204" pitchFamily="18" charset="0"/>
+                              </a:rPr>
+                              <m:t>1</m:t>
                             </m:r>
                           </m:lim>
                         </m:limLow>
@@ -11616,7 +11631,43 @@
                         </a:solidFill>
                         <a:latin typeface="Cambria Math" panose="02040503050406030204" pitchFamily="18" charset="0"/>
                       </a:rPr>
-                      <m:t>=(0/54);</m:t>
+                      <m:t>=(</m:t>
+                    </m:r>
+                    <m:r>
+                      <a:rPr sz="2285" i="1">
+                        <a:solidFill>
+                          <a:srgbClr val="000000"/>
+                        </a:solidFill>
+                        <a:latin typeface="Cambria Math" panose="02040503050406030204" pitchFamily="18" charset="0"/>
+                      </a:rPr>
+                      <m:t>0</m:t>
+                    </m:r>
+                    <m:r>
+                      <a:rPr sz="2285" i="1">
+                        <a:solidFill>
+                          <a:srgbClr val="000000"/>
+                        </a:solidFill>
+                        <a:latin typeface="Cambria Math" panose="02040503050406030204" pitchFamily="18" charset="0"/>
+                      </a:rPr>
+                      <m:t>/</m:t>
+                    </m:r>
+                    <m:r>
+                      <a:rPr sz="2285" i="1">
+                        <a:solidFill>
+                          <a:srgbClr val="000000"/>
+                        </a:solidFill>
+                        <a:latin typeface="Cambria Math" panose="02040503050406030204" pitchFamily="18" charset="0"/>
+                      </a:rPr>
+                      <m:t>54</m:t>
+                    </m:r>
+                    <m:r>
+                      <a:rPr sz="2285" i="1">
+                        <a:solidFill>
+                          <a:srgbClr val="000000"/>
+                        </a:solidFill>
+                        <a:latin typeface="Cambria Math" panose="02040503050406030204" pitchFamily="18" charset="0"/>
+                      </a:rPr>
+                      <m:t>);</m:t>
                     </m:r>
                     <m:r>
                       <m:rPr>
@@ -11680,7 +11731,43 @@
                         </a:solidFill>
                         <a:latin typeface="Cambria Math" panose="02040503050406030204" pitchFamily="18" charset="0"/>
                       </a:rPr>
-                      <m:t>=(49/54);</m:t>
+                      <m:t>=(</m:t>
+                    </m:r>
+                    <m:r>
+                      <a:rPr sz="2285" i="1">
+                        <a:solidFill>
+                          <a:srgbClr val="000000"/>
+                        </a:solidFill>
+                        <a:latin typeface="Cambria Math" panose="02040503050406030204" pitchFamily="18" charset="0"/>
+                      </a:rPr>
+                      <m:t>49</m:t>
+                    </m:r>
+                    <m:r>
+                      <a:rPr sz="2285" i="1">
+                        <a:solidFill>
+                          <a:srgbClr val="000000"/>
+                        </a:solidFill>
+                        <a:latin typeface="Cambria Math" panose="02040503050406030204" pitchFamily="18" charset="0"/>
+                      </a:rPr>
+                      <m:t>/</m:t>
+                    </m:r>
+                    <m:r>
+                      <a:rPr sz="2285" i="1">
+                        <a:solidFill>
+                          <a:srgbClr val="000000"/>
+                        </a:solidFill>
+                        <a:latin typeface="Cambria Math" panose="02040503050406030204" pitchFamily="18" charset="0"/>
+                      </a:rPr>
+                      <m:t>54</m:t>
+                    </m:r>
+                    <m:r>
+                      <a:rPr sz="2285" i="1">
+                        <a:solidFill>
+                          <a:srgbClr val="000000"/>
+                        </a:solidFill>
+                        <a:latin typeface="Cambria Math" panose="02040503050406030204" pitchFamily="18" charset="0"/>
+                      </a:rPr>
+                      <m:t>);</m:t>
                     </m:r>
                     <m:r>
                       <m:rPr>
@@ -11744,7 +11831,43 @@
                         </a:solidFill>
                         <a:latin typeface="Cambria Math" panose="02040503050406030204" pitchFamily="18" charset="0"/>
                       </a:rPr>
-                      <m:t>=(5/54)</m:t>
+                      <m:t>=(</m:t>
+                    </m:r>
+                    <m:r>
+                      <a:rPr sz="2285" i="1">
+                        <a:solidFill>
+                          <a:srgbClr val="000000"/>
+                        </a:solidFill>
+                        <a:latin typeface="Cambria Math" panose="02040503050406030204" pitchFamily="18" charset="0"/>
+                      </a:rPr>
+                      <m:t>5</m:t>
+                    </m:r>
+                    <m:r>
+                      <a:rPr sz="2285" i="1">
+                        <a:solidFill>
+                          <a:srgbClr val="000000"/>
+                        </a:solidFill>
+                        <a:latin typeface="Cambria Math" panose="02040503050406030204" pitchFamily="18" charset="0"/>
+                      </a:rPr>
+                      <m:t>/</m:t>
+                    </m:r>
+                    <m:r>
+                      <a:rPr sz="2285" i="1">
+                        <a:solidFill>
+                          <a:srgbClr val="000000"/>
+                        </a:solidFill>
+                        <a:latin typeface="Cambria Math" panose="02040503050406030204" pitchFamily="18" charset="0"/>
+                      </a:rPr>
+                      <m:t>54</m:t>
+                    </m:r>
+                    <m:r>
+                      <a:rPr sz="2285" i="1">
+                        <a:solidFill>
+                          <a:srgbClr val="000000"/>
+                        </a:solidFill>
+                        <a:latin typeface="Cambria Math" panose="02040503050406030204" pitchFamily="18" charset="0"/>
+                      </a:rPr>
+                      <m:t>)</m:t>
                     </m:r>
                   </m:oMath>
                 </a14:m>
@@ -11797,7 +11920,25 @@
                         </a:solidFill>
                         <a:latin typeface="Cambria Math" panose="02040503050406030204" pitchFamily="18" charset="0"/>
                       </a:rPr>
-                      <m:t>=1−</m:t>
+                      <m:t>=</m:t>
+                    </m:r>
+                    <m:r>
+                      <a:rPr sz="2285" i="1">
+                        <a:solidFill>
+                          <a:srgbClr val="000000"/>
+                        </a:solidFill>
+                        <a:latin typeface="Cambria Math" panose="02040503050406030204" pitchFamily="18" charset="0"/>
+                      </a:rPr>
+                      <m:t>1</m:t>
+                    </m:r>
+                    <m:r>
+                      <a:rPr sz="2285" i="1">
+                        <a:solidFill>
+                          <a:srgbClr val="000000"/>
+                        </a:solidFill>
+                        <a:latin typeface="Cambria Math" panose="02040503050406030204" pitchFamily="18" charset="0"/>
+                      </a:rPr>
+                      <m:t>−</m:t>
                     </m:r>
                     <m:d>
                       <m:dPr>
@@ -11818,7 +11959,34 @@
                             </a:solidFill>
                             <a:latin typeface="Cambria Math" panose="02040503050406030204" pitchFamily="18" charset="0"/>
                           </a:rPr>
-                          <m:t>(0/54</m:t>
+                          <m:t>(</m:t>
+                        </m:r>
+                        <m:r>
+                          <a:rPr sz="2285" i="1">
+                            <a:solidFill>
+                              <a:srgbClr val="000000"/>
+                            </a:solidFill>
+                            <a:latin typeface="Cambria Math" panose="02040503050406030204" pitchFamily="18" charset="0"/>
+                          </a:rPr>
+                          <m:t>0</m:t>
+                        </m:r>
+                        <m:r>
+                          <a:rPr sz="2285" i="1">
+                            <a:solidFill>
+                              <a:srgbClr val="000000"/>
+                            </a:solidFill>
+                            <a:latin typeface="Cambria Math" panose="02040503050406030204" pitchFamily="18" charset="0"/>
+                          </a:rPr>
+                          <m:t>/</m:t>
+                        </m:r>
+                        <m:r>
+                          <a:rPr sz="2285" i="1">
+                            <a:solidFill>
+                              <a:srgbClr val="000000"/>
+                            </a:solidFill>
+                            <a:latin typeface="Cambria Math" panose="02040503050406030204" pitchFamily="18" charset="0"/>
+                          </a:rPr>
+                          <m:t>54</m:t>
                         </m:r>
                         <m:sSup>
                           <m:sSupPr>
@@ -11861,7 +12029,34 @@
                             </a:solidFill>
                             <a:latin typeface="Cambria Math" panose="02040503050406030204" pitchFamily="18" charset="0"/>
                           </a:rPr>
-                          <m:t>+(49/54</m:t>
+                          <m:t>+(</m:t>
+                        </m:r>
+                        <m:r>
+                          <a:rPr sz="2285" i="1">
+                            <a:solidFill>
+                              <a:srgbClr val="000000"/>
+                            </a:solidFill>
+                            <a:latin typeface="Cambria Math" panose="02040503050406030204" pitchFamily="18" charset="0"/>
+                          </a:rPr>
+                          <m:t>49</m:t>
+                        </m:r>
+                        <m:r>
+                          <a:rPr sz="2285" i="1">
+                            <a:solidFill>
+                              <a:srgbClr val="000000"/>
+                            </a:solidFill>
+                            <a:latin typeface="Cambria Math" panose="02040503050406030204" pitchFamily="18" charset="0"/>
+                          </a:rPr>
+                          <m:t>/</m:t>
+                        </m:r>
+                        <m:r>
+                          <a:rPr sz="2285" i="1">
+                            <a:solidFill>
+                              <a:srgbClr val="000000"/>
+                            </a:solidFill>
+                            <a:latin typeface="Cambria Math" panose="02040503050406030204" pitchFamily="18" charset="0"/>
+                          </a:rPr>
+                          <m:t>54</m:t>
                         </m:r>
                         <m:sSup>
                           <m:sSupPr>
@@ -11904,7 +12099,34 @@
                             </a:solidFill>
                             <a:latin typeface="Cambria Math" panose="02040503050406030204" pitchFamily="18" charset="0"/>
                           </a:rPr>
-                          <m:t>+(5/54</m:t>
+                          <m:t>+(</m:t>
+                        </m:r>
+                        <m:r>
+                          <a:rPr sz="2285" i="1">
+                            <a:solidFill>
+                              <a:srgbClr val="000000"/>
+                            </a:solidFill>
+                            <a:latin typeface="Cambria Math" panose="02040503050406030204" pitchFamily="18" charset="0"/>
+                          </a:rPr>
+                          <m:t>5</m:t>
+                        </m:r>
+                        <m:r>
+                          <a:rPr sz="2285" i="1">
+                            <a:solidFill>
+                              <a:srgbClr val="000000"/>
+                            </a:solidFill>
+                            <a:latin typeface="Cambria Math" panose="02040503050406030204" pitchFamily="18" charset="0"/>
+                          </a:rPr>
+                          <m:t>/</m:t>
+                        </m:r>
+                        <m:r>
+                          <a:rPr sz="2285" i="1">
+                            <a:solidFill>
+                              <a:srgbClr val="000000"/>
+                            </a:solidFill>
+                            <a:latin typeface="Cambria Math" panose="02040503050406030204" pitchFamily="18" charset="0"/>
+                          </a:rPr>
+                          <m:t>54</m:t>
                         </m:r>
                         <m:sSup>
                           <m:sSupPr>
@@ -11956,7 +12178,34 @@
                         </a:solidFill>
                         <a:latin typeface="Cambria Math" panose="02040503050406030204" pitchFamily="18" charset="0"/>
                       </a:rPr>
-                      <m:t>=0.168</m:t>
+                      <m:t>=</m:t>
+                    </m:r>
+                    <m:r>
+                      <a:rPr sz="2285" i="1">
+                        <a:solidFill>
+                          <a:srgbClr val="000000"/>
+                        </a:solidFill>
+                        <a:latin typeface="Cambria Math" panose="02040503050406030204" pitchFamily="18" charset="0"/>
+                      </a:rPr>
+                      <m:t>0</m:t>
+                    </m:r>
+                    <m:r>
+                      <a:rPr sz="2285" i="1">
+                        <a:solidFill>
+                          <a:srgbClr val="000000"/>
+                        </a:solidFill>
+                        <a:latin typeface="Cambria Math" panose="02040503050406030204" pitchFamily="18" charset="0"/>
+                      </a:rPr>
+                      <m:t>.</m:t>
+                    </m:r>
+                    <m:r>
+                      <a:rPr sz="2285" i="1">
+                        <a:solidFill>
+                          <a:srgbClr val="000000"/>
+                        </a:solidFill>
+                        <a:latin typeface="Cambria Math" panose="02040503050406030204" pitchFamily="18" charset="0"/>
+                      </a:rPr>
+                      <m:t>168</m:t>
                     </m:r>
                   </m:oMath>
                 </a14:m>
@@ -12022,7 +12271,43 @@
                         </a:solidFill>
                         <a:latin typeface="Cambria Math" panose="02040503050406030204" pitchFamily="18" charset="0"/>
                       </a:rPr>
-                      <m:t>=(0/46);</m:t>
+                      <m:t>=(</m:t>
+                    </m:r>
+                    <m:r>
+                      <a:rPr sz="2285" i="1">
+                        <a:solidFill>
+                          <a:srgbClr val="000000"/>
+                        </a:solidFill>
+                        <a:latin typeface="Cambria Math" panose="02040503050406030204" pitchFamily="18" charset="0"/>
+                      </a:rPr>
+                      <m:t>0</m:t>
+                    </m:r>
+                    <m:r>
+                      <a:rPr sz="2285" i="1">
+                        <a:solidFill>
+                          <a:srgbClr val="000000"/>
+                        </a:solidFill>
+                        <a:latin typeface="Cambria Math" panose="02040503050406030204" pitchFamily="18" charset="0"/>
+                      </a:rPr>
+                      <m:t>/</m:t>
+                    </m:r>
+                    <m:r>
+                      <a:rPr sz="2285" i="1">
+                        <a:solidFill>
+                          <a:srgbClr val="000000"/>
+                        </a:solidFill>
+                        <a:latin typeface="Cambria Math" panose="02040503050406030204" pitchFamily="18" charset="0"/>
+                      </a:rPr>
+                      <m:t>46</m:t>
+                    </m:r>
+                    <m:r>
+                      <a:rPr sz="2285" i="1">
+                        <a:solidFill>
+                          <a:srgbClr val="000000"/>
+                        </a:solidFill>
+                        <a:latin typeface="Cambria Math" panose="02040503050406030204" pitchFamily="18" charset="0"/>
+                      </a:rPr>
+                      <m:t>);</m:t>
                     </m:r>
                     <m:r>
                       <m:rPr>
@@ -12086,7 +12371,43 @@
                         </a:solidFill>
                         <a:latin typeface="Cambria Math" panose="02040503050406030204" pitchFamily="18" charset="0"/>
                       </a:rPr>
-                      <m:t>=(1/46);</m:t>
+                      <m:t>=(</m:t>
+                    </m:r>
+                    <m:r>
+                      <a:rPr sz="2285" i="1">
+                        <a:solidFill>
+                          <a:srgbClr val="000000"/>
+                        </a:solidFill>
+                        <a:latin typeface="Cambria Math" panose="02040503050406030204" pitchFamily="18" charset="0"/>
+                      </a:rPr>
+                      <m:t>1</m:t>
+                    </m:r>
+                    <m:r>
+                      <a:rPr sz="2285" i="1">
+                        <a:solidFill>
+                          <a:srgbClr val="000000"/>
+                        </a:solidFill>
+                        <a:latin typeface="Cambria Math" panose="02040503050406030204" pitchFamily="18" charset="0"/>
+                      </a:rPr>
+                      <m:t>/</m:t>
+                    </m:r>
+                    <m:r>
+                      <a:rPr sz="2285" i="1">
+                        <a:solidFill>
+                          <a:srgbClr val="000000"/>
+                        </a:solidFill>
+                        <a:latin typeface="Cambria Math" panose="02040503050406030204" pitchFamily="18" charset="0"/>
+                      </a:rPr>
+                      <m:t>46</m:t>
+                    </m:r>
+                    <m:r>
+                      <a:rPr sz="2285" i="1">
+                        <a:solidFill>
+                          <a:srgbClr val="000000"/>
+                        </a:solidFill>
+                        <a:latin typeface="Cambria Math" panose="02040503050406030204" pitchFamily="18" charset="0"/>
+                      </a:rPr>
+                      <m:t>);</m:t>
                     </m:r>
                     <m:r>
                       <m:rPr>
@@ -12150,7 +12471,43 @@
                         </a:solidFill>
                         <a:latin typeface="Cambria Math" panose="02040503050406030204" pitchFamily="18" charset="0"/>
                       </a:rPr>
-                      <m:t>=(45/46)</m:t>
+                      <m:t>=(</m:t>
+                    </m:r>
+                    <m:r>
+                      <a:rPr sz="2285" i="1">
+                        <a:solidFill>
+                          <a:srgbClr val="000000"/>
+                        </a:solidFill>
+                        <a:latin typeface="Cambria Math" panose="02040503050406030204" pitchFamily="18" charset="0"/>
+                      </a:rPr>
+                      <m:t>45</m:t>
+                    </m:r>
+                    <m:r>
+                      <a:rPr sz="2285" i="1">
+                        <a:solidFill>
+                          <a:srgbClr val="000000"/>
+                        </a:solidFill>
+                        <a:latin typeface="Cambria Math" panose="02040503050406030204" pitchFamily="18" charset="0"/>
+                      </a:rPr>
+                      <m:t>/</m:t>
+                    </m:r>
+                    <m:r>
+                      <a:rPr sz="2285" i="1">
+                        <a:solidFill>
+                          <a:srgbClr val="000000"/>
+                        </a:solidFill>
+                        <a:latin typeface="Cambria Math" panose="02040503050406030204" pitchFamily="18" charset="0"/>
+                      </a:rPr>
+                      <m:t>46</m:t>
+                    </m:r>
+                    <m:r>
+                      <a:rPr sz="2285" i="1">
+                        <a:solidFill>
+                          <a:srgbClr val="000000"/>
+                        </a:solidFill>
+                        <a:latin typeface="Cambria Math" panose="02040503050406030204" pitchFamily="18" charset="0"/>
+                      </a:rPr>
+                      <m:t>)</m:t>
                     </m:r>
                   </m:oMath>
                 </a14:m>
@@ -12203,7 +12560,25 @@
                         </a:solidFill>
                         <a:latin typeface="Cambria Math" panose="02040503050406030204" pitchFamily="18" charset="0"/>
                       </a:rPr>
-                      <m:t>=1−</m:t>
+                      <m:t>=</m:t>
+                    </m:r>
+                    <m:r>
+                      <a:rPr sz="2285" i="1">
+                        <a:solidFill>
+                          <a:srgbClr val="000000"/>
+                        </a:solidFill>
+                        <a:latin typeface="Cambria Math" panose="02040503050406030204" pitchFamily="18" charset="0"/>
+                      </a:rPr>
+                      <m:t>1</m:t>
+                    </m:r>
+                    <m:r>
+                      <a:rPr sz="2285" i="1">
+                        <a:solidFill>
+                          <a:srgbClr val="000000"/>
+                        </a:solidFill>
+                        <a:latin typeface="Cambria Math" panose="02040503050406030204" pitchFamily="18" charset="0"/>
+                      </a:rPr>
+                      <m:t>−</m:t>
                     </m:r>
                     <m:d>
                       <m:dPr>
@@ -12224,7 +12599,34 @@
                             </a:solidFill>
                             <a:latin typeface="Cambria Math" panose="02040503050406030204" pitchFamily="18" charset="0"/>
                           </a:rPr>
-                          <m:t>(0/46</m:t>
+                          <m:t>(</m:t>
+                        </m:r>
+                        <m:r>
+                          <a:rPr sz="2285" i="1">
+                            <a:solidFill>
+                              <a:srgbClr val="000000"/>
+                            </a:solidFill>
+                            <a:latin typeface="Cambria Math" panose="02040503050406030204" pitchFamily="18" charset="0"/>
+                          </a:rPr>
+                          <m:t>0</m:t>
+                        </m:r>
+                        <m:r>
+                          <a:rPr sz="2285" i="1">
+                            <a:solidFill>
+                              <a:srgbClr val="000000"/>
+                            </a:solidFill>
+                            <a:latin typeface="Cambria Math" panose="02040503050406030204" pitchFamily="18" charset="0"/>
+                          </a:rPr>
+                          <m:t>/</m:t>
+                        </m:r>
+                        <m:r>
+                          <a:rPr sz="2285" i="1">
+                            <a:solidFill>
+                              <a:srgbClr val="000000"/>
+                            </a:solidFill>
+                            <a:latin typeface="Cambria Math" panose="02040503050406030204" pitchFamily="18" charset="0"/>
+                          </a:rPr>
+                          <m:t>46</m:t>
                         </m:r>
                         <m:sSup>
                           <m:sSupPr>
@@ -12267,7 +12669,34 @@
                             </a:solidFill>
                             <a:latin typeface="Cambria Math" panose="02040503050406030204" pitchFamily="18" charset="0"/>
                           </a:rPr>
-                          <m:t>+(1/46</m:t>
+                          <m:t>+(</m:t>
+                        </m:r>
+                        <m:r>
+                          <a:rPr sz="2285" i="1">
+                            <a:solidFill>
+                              <a:srgbClr val="000000"/>
+                            </a:solidFill>
+                            <a:latin typeface="Cambria Math" panose="02040503050406030204" pitchFamily="18" charset="0"/>
+                          </a:rPr>
+                          <m:t>1</m:t>
+                        </m:r>
+                        <m:r>
+                          <a:rPr sz="2285" i="1">
+                            <a:solidFill>
+                              <a:srgbClr val="000000"/>
+                            </a:solidFill>
+                            <a:latin typeface="Cambria Math" panose="02040503050406030204" pitchFamily="18" charset="0"/>
+                          </a:rPr>
+                          <m:t>/</m:t>
+                        </m:r>
+                        <m:r>
+                          <a:rPr sz="2285" i="1">
+                            <a:solidFill>
+                              <a:srgbClr val="000000"/>
+                            </a:solidFill>
+                            <a:latin typeface="Cambria Math" panose="02040503050406030204" pitchFamily="18" charset="0"/>
+                          </a:rPr>
+                          <m:t>46</m:t>
                         </m:r>
                         <m:sSup>
                           <m:sSupPr>
@@ -12310,7 +12739,34 @@
                             </a:solidFill>
                             <a:latin typeface="Cambria Math" panose="02040503050406030204" pitchFamily="18" charset="0"/>
                           </a:rPr>
-                          <m:t>+(45/46</m:t>
+                          <m:t>+(</m:t>
+                        </m:r>
+                        <m:r>
+                          <a:rPr sz="2285" i="1">
+                            <a:solidFill>
+                              <a:srgbClr val="000000"/>
+                            </a:solidFill>
+                            <a:latin typeface="Cambria Math" panose="02040503050406030204" pitchFamily="18" charset="0"/>
+                          </a:rPr>
+                          <m:t>45</m:t>
+                        </m:r>
+                        <m:r>
+                          <a:rPr sz="2285" i="1">
+                            <a:solidFill>
+                              <a:srgbClr val="000000"/>
+                            </a:solidFill>
+                            <a:latin typeface="Cambria Math" panose="02040503050406030204" pitchFamily="18" charset="0"/>
+                          </a:rPr>
+                          <m:t>/</m:t>
+                        </m:r>
+                        <m:r>
+                          <a:rPr sz="2285" i="1">
+                            <a:solidFill>
+                              <a:srgbClr val="000000"/>
+                            </a:solidFill>
+                            <a:latin typeface="Cambria Math" panose="02040503050406030204" pitchFamily="18" charset="0"/>
+                          </a:rPr>
+                          <m:t>46</m:t>
                         </m:r>
                         <m:sSup>
                           <m:sSupPr>
@@ -12362,7 +12818,34 @@
                         </a:solidFill>
                         <a:latin typeface="Cambria Math" panose="02040503050406030204" pitchFamily="18" charset="0"/>
                       </a:rPr>
-                      <m:t>=0.043</m:t>
+                      <m:t>=</m:t>
+                    </m:r>
+                    <m:r>
+                      <a:rPr sz="2285" i="1">
+                        <a:solidFill>
+                          <a:srgbClr val="000000"/>
+                        </a:solidFill>
+                        <a:latin typeface="Cambria Math" panose="02040503050406030204" pitchFamily="18" charset="0"/>
+                      </a:rPr>
+                      <m:t>0</m:t>
+                    </m:r>
+                    <m:r>
+                      <a:rPr sz="2285" i="1">
+                        <a:solidFill>
+                          <a:srgbClr val="000000"/>
+                        </a:solidFill>
+                        <a:latin typeface="Cambria Math" panose="02040503050406030204" pitchFamily="18" charset="0"/>
+                      </a:rPr>
+                      <m:t>.</m:t>
+                    </m:r>
+                    <m:r>
+                      <a:rPr sz="2285" i="1">
+                        <a:solidFill>
+                          <a:srgbClr val="000000"/>
+                        </a:solidFill>
+                        <a:latin typeface="Cambria Math" panose="02040503050406030204" pitchFamily="18" charset="0"/>
+                      </a:rPr>
+                      <m:t>043</m:t>
                     </m:r>
                   </m:oMath>
                 </a14:m>

</xml_diff>